<commit_message>
presentación: fuera las sombras, y se acompaña de un PDF
En la vista previa del iPhone aparecían recuadros blancos encima del
contenido — incluso en una lámina que no tiene ni una tarjeta, solo círculos
y texto, así que no salían del archivo. Es el visor del teléfono pintando
mal mientras se hace scroll.

Aun así se quitan las sombras: son el efecto que más difiere entre visores y
aquí no hacían falta, porque las tarjetas ya se distinguen por su borde y su
tinte. Menos cosas que un renderizador pueda malinterpretar.

Se agrega pdf.js: genera un PDF desde el mismo visor, que se ve igual en
cualquier teléfono. Sirve para separar "está mal el archivo" de "lo está
dibujando mal el visor" — que es justo la duda que costó esta ronda.

Co-Authored-By: Claude Opus 5 <noreply@anthropic.com>
Claude-Session: https://claude.ai/code/session_018vHmmmDsoEfgzHDXUQjXcv
</commit_message>
<xml_diff>
--- a/presentacion/sistema-ciudad-maderas.pptx
+++ b/presentacion/sistema-ciudad-maderas.pptx
@@ -2573,13 +2573,6 @@
             </a:solidFill>
             <a:prstDash val="solid"/>
           </a:ln>
-          <a:effectLst>
-            <a:outerShdw sx="100000" sy="100000" kx="0" ky="0" algn="bl" rotWithShape="0" blurRad="127000" dist="25400" dir="5400000">
-              <a:srgbClr val="9AA7B2">
-                <a:alpha val="18000"/>
-              </a:srgbClr>
-            </a:outerShdw>
-          </a:effectLst>
         </p:spPr>
       </p:sp>
       <p:sp>
@@ -3008,13 +3001,6 @@
             </a:solidFill>
             <a:prstDash val="solid"/>
           </a:ln>
-          <a:effectLst>
-            <a:outerShdw sx="100000" sy="100000" kx="0" ky="0" algn="bl" rotWithShape="0" blurRad="127000" dist="25400" dir="5400000">
-              <a:srgbClr val="9AA7B2">
-                <a:alpha val="18000"/>
-              </a:srgbClr>
-            </a:outerShdw>
-          </a:effectLst>
         </p:spPr>
       </p:sp>
       <p:sp>
@@ -3120,13 +3106,6 @@
             </a:solidFill>
             <a:prstDash val="solid"/>
           </a:ln>
-          <a:effectLst>
-            <a:outerShdw sx="100000" sy="100000" kx="0" ky="0" algn="bl" rotWithShape="0" blurRad="127000" dist="25400" dir="5400000">
-              <a:srgbClr val="9AA7B2">
-                <a:alpha val="18000"/>
-              </a:srgbClr>
-            </a:outerShdw>
-          </a:effectLst>
         </p:spPr>
       </p:sp>
       <p:sp>
@@ -3303,13 +3282,6 @@
             </a:solidFill>
             <a:prstDash val="solid"/>
           </a:ln>
-          <a:effectLst>
-            <a:outerShdw sx="100000" sy="100000" kx="0" ky="0" algn="bl" rotWithShape="0" blurRad="127000" dist="25400" dir="5400000">
-              <a:srgbClr val="9AA7B2">
-                <a:alpha val="18000"/>
-              </a:srgbClr>
-            </a:outerShdw>
-          </a:effectLst>
         </p:spPr>
       </p:sp>
       <p:sp>
@@ -3501,13 +3473,6 @@
             </a:solidFill>
             <a:prstDash val="solid"/>
           </a:ln>
-          <a:effectLst>
-            <a:outerShdw sx="100000" sy="100000" kx="0" ky="0" algn="bl" rotWithShape="0" blurRad="127000" dist="25400" dir="5400000">
-              <a:srgbClr val="9AA7B2">
-                <a:alpha val="18000"/>
-              </a:srgbClr>
-            </a:outerShdw>
-          </a:effectLst>
         </p:spPr>
       </p:sp>
       <p:sp>
@@ -3699,13 +3664,6 @@
             </a:solidFill>
             <a:prstDash val="solid"/>
           </a:ln>
-          <a:effectLst>
-            <a:outerShdw sx="100000" sy="100000" kx="0" ky="0" algn="bl" rotWithShape="0" blurRad="127000" dist="25400" dir="5400000">
-              <a:srgbClr val="9AA7B2">
-                <a:alpha val="18000"/>
-              </a:srgbClr>
-            </a:outerShdw>
-          </a:effectLst>
         </p:spPr>
       </p:sp>
       <p:sp>
@@ -3882,13 +3840,6 @@
             </a:solidFill>
             <a:prstDash val="solid"/>
           </a:ln>
-          <a:effectLst>
-            <a:outerShdw sx="100000" sy="100000" kx="0" ky="0" algn="bl" rotWithShape="0" blurRad="127000" dist="25400" dir="5400000">
-              <a:srgbClr val="9AA7B2">
-                <a:alpha val="18000"/>
-              </a:srgbClr>
-            </a:outerShdw>
-          </a:effectLst>
         </p:spPr>
       </p:sp>
       <p:sp>
@@ -4103,13 +4054,6 @@
             </a:solidFill>
             <a:prstDash val="solid"/>
           </a:ln>
-          <a:effectLst>
-            <a:outerShdw sx="100000" sy="100000" kx="0" ky="0" algn="bl" rotWithShape="0" blurRad="127000" dist="25400" dir="5400000">
-              <a:srgbClr val="9AA7B2">
-                <a:alpha val="18000"/>
-              </a:srgbClr>
-            </a:outerShdw>
-          </a:effectLst>
         </p:spPr>
       </p:sp>
       <p:sp>
@@ -4301,13 +4245,6 @@
             </a:solidFill>
             <a:prstDash val="solid"/>
           </a:ln>
-          <a:effectLst>
-            <a:outerShdw sx="100000" sy="100000" kx="0" ky="0" algn="bl" rotWithShape="0" blurRad="127000" dist="25400" dir="5400000">
-              <a:srgbClr val="9AA7B2">
-                <a:alpha val="18000"/>
-              </a:srgbClr>
-            </a:outerShdw>
-          </a:effectLst>
         </p:spPr>
       </p:sp>
       <p:sp>
@@ -5521,13 +5458,6 @@
             </a:solidFill>
             <a:prstDash val="solid"/>
           </a:ln>
-          <a:effectLst>
-            <a:outerShdw sx="100000" sy="100000" kx="0" ky="0" algn="bl" rotWithShape="0" blurRad="127000" dist="25400" dir="5400000">
-              <a:srgbClr val="9AA7B2">
-                <a:alpha val="18000"/>
-              </a:srgbClr>
-            </a:outerShdw>
-          </a:effectLst>
         </p:spPr>
       </p:sp>
       <p:sp>
@@ -5658,13 +5588,6 @@
             </a:solidFill>
             <a:prstDash val="solid"/>
           </a:ln>
-          <a:effectLst>
-            <a:outerShdw sx="100000" sy="100000" kx="0" ky="0" algn="bl" rotWithShape="0" blurRad="127000" dist="25400" dir="5400000">
-              <a:srgbClr val="9AA7B2">
-                <a:alpha val="18000"/>
-              </a:srgbClr>
-            </a:outerShdw>
-          </a:effectLst>
         </p:spPr>
       </p:sp>
       <p:sp>
@@ -6285,14 +6208,12 @@
           <a:solidFill>
             <a:srgbClr val="FFFFFF"/>
           </a:solidFill>
-          <a:ln/>
-          <a:effectLst>
-            <a:outerShdw sx="100000" sy="100000" kx="0" ky="0" algn="bl" rotWithShape="0" blurRad="203200" dist="38100" dir="5400000">
-              <a:srgbClr val="000000">
-                <a:alpha val="30000"/>
-              </a:srgbClr>
-            </a:outerShdw>
-          </a:effectLst>
+          <a:ln w="12700">
+            <a:solidFill>
+              <a:srgbClr val="C9D4DC"/>
+            </a:solidFill>
+            <a:prstDash val="solid"/>
+          </a:ln>
         </p:spPr>
       </p:sp>
       <p:sp>
@@ -7015,13 +6936,6 @@
             </a:solidFill>
             <a:prstDash val="solid"/>
           </a:ln>
-          <a:effectLst>
-            <a:outerShdw sx="100000" sy="100000" kx="0" ky="0" algn="bl" rotWithShape="0" blurRad="127000" dist="25400" dir="5400000">
-              <a:srgbClr val="9AA7B2">
-                <a:alpha val="18000"/>
-              </a:srgbClr>
-            </a:outerShdw>
-          </a:effectLst>
         </p:spPr>
       </p:sp>
       <p:sp>
@@ -7150,13 +7064,6 @@
             </a:solidFill>
             <a:prstDash val="solid"/>
           </a:ln>
-          <a:effectLst>
-            <a:outerShdw sx="100000" sy="100000" kx="0" ky="0" algn="bl" rotWithShape="0" blurRad="127000" dist="25400" dir="5400000">
-              <a:srgbClr val="9AA7B2">
-                <a:alpha val="18000"/>
-              </a:srgbClr>
-            </a:outerShdw>
-          </a:effectLst>
         </p:spPr>
       </p:sp>
       <p:sp>
@@ -8671,13 +8578,6 @@
             </a:solidFill>
             <a:prstDash val="solid"/>
           </a:ln>
-          <a:effectLst>
-            <a:outerShdw sx="100000" sy="100000" kx="0" ky="0" algn="bl" rotWithShape="0" blurRad="127000" dist="25400" dir="5400000">
-              <a:srgbClr val="9AA7B2">
-                <a:alpha val="18000"/>
-              </a:srgbClr>
-            </a:outerShdw>
-          </a:effectLst>
         </p:spPr>
       </p:sp>
       <p:sp>
@@ -8842,13 +8742,6 @@
             </a:solidFill>
             <a:prstDash val="solid"/>
           </a:ln>
-          <a:effectLst>
-            <a:outerShdw sx="100000" sy="100000" kx="0" ky="0" algn="bl" rotWithShape="0" blurRad="127000" dist="25400" dir="5400000">
-              <a:srgbClr val="9AA7B2">
-                <a:alpha val="18000"/>
-              </a:srgbClr>
-            </a:outerShdw>
-          </a:effectLst>
         </p:spPr>
       </p:sp>
       <p:sp>
@@ -9013,13 +8906,6 @@
             </a:solidFill>
             <a:prstDash val="solid"/>
           </a:ln>
-          <a:effectLst>
-            <a:outerShdw sx="100000" sy="100000" kx="0" ky="0" algn="bl" rotWithShape="0" blurRad="127000" dist="25400" dir="5400000">
-              <a:srgbClr val="9AA7B2">
-                <a:alpha val="18000"/>
-              </a:srgbClr>
-            </a:outerShdw>
-          </a:effectLst>
         </p:spPr>
       </p:sp>
       <p:sp>
@@ -9333,13 +9219,6 @@
             </a:solidFill>
             <a:prstDash val="solid"/>
           </a:ln>
-          <a:effectLst>
-            <a:outerShdw sx="100000" sy="100000" kx="0" ky="0" algn="bl" rotWithShape="0" blurRad="127000" dist="25400" dir="5400000">
-              <a:srgbClr val="9AA7B2">
-                <a:alpha val="18000"/>
-              </a:srgbClr>
-            </a:outerShdw>
-          </a:effectLst>
         </p:spPr>
       </p:sp>
       <p:sp>
@@ -9577,13 +9456,6 @@
             </a:solidFill>
             <a:prstDash val="solid"/>
           </a:ln>
-          <a:effectLst>
-            <a:outerShdw sx="100000" sy="100000" kx="0" ky="0" algn="bl" rotWithShape="0" blurRad="127000" dist="25400" dir="5400000">
-              <a:srgbClr val="9AA7B2">
-                <a:alpha val="18000"/>
-              </a:srgbClr>
-            </a:outerShdw>
-          </a:effectLst>
         </p:spPr>
       </p:sp>
       <p:sp>
@@ -9821,13 +9693,6 @@
             </a:solidFill>
             <a:prstDash val="solid"/>
           </a:ln>
-          <a:effectLst>
-            <a:outerShdw sx="100000" sy="100000" kx="0" ky="0" algn="bl" rotWithShape="0" blurRad="127000" dist="25400" dir="5400000">
-              <a:srgbClr val="9AA7B2">
-                <a:alpha val="18000"/>
-              </a:srgbClr>
-            </a:outerShdw>
-          </a:effectLst>
         </p:spPr>
       </p:sp>
       <p:sp>
@@ -10065,13 +9930,6 @@
             </a:solidFill>
             <a:prstDash val="solid"/>
           </a:ln>
-          <a:effectLst>
-            <a:outerShdw sx="100000" sy="100000" kx="0" ky="0" algn="bl" rotWithShape="0" blurRad="127000" dist="25400" dir="5400000">
-              <a:srgbClr val="9AA7B2">
-                <a:alpha val="18000"/>
-              </a:srgbClr>
-            </a:outerShdw>
-          </a:effectLst>
         </p:spPr>
       </p:sp>
       <p:sp>
@@ -10309,13 +10167,6 @@
             </a:solidFill>
             <a:prstDash val="solid"/>
           </a:ln>
-          <a:effectLst>
-            <a:outerShdw sx="100000" sy="100000" kx="0" ky="0" algn="bl" rotWithShape="0" blurRad="127000" dist="25400" dir="5400000">
-              <a:srgbClr val="9AA7B2">
-                <a:alpha val="18000"/>
-              </a:srgbClr>
-            </a:outerShdw>
-          </a:effectLst>
         </p:spPr>
       </p:sp>
       <p:sp>
@@ -10663,13 +10514,6 @@
             </a:solidFill>
             <a:prstDash val="solid"/>
           </a:ln>
-          <a:effectLst>
-            <a:outerShdw sx="100000" sy="100000" kx="0" ky="0" algn="bl" rotWithShape="0" blurRad="127000" dist="25400" dir="5400000">
-              <a:srgbClr val="9AA7B2">
-                <a:alpha val="18000"/>
-              </a:srgbClr>
-            </a:outerShdw>
-          </a:effectLst>
         </p:spPr>
       </p:sp>
       <p:sp>
@@ -10841,13 +10685,6 @@
             </a:solidFill>
             <a:prstDash val="solid"/>
           </a:ln>
-          <a:effectLst>
-            <a:outerShdw sx="100000" sy="100000" kx="0" ky="0" algn="bl" rotWithShape="0" blurRad="127000" dist="25400" dir="5400000">
-              <a:srgbClr val="9AA7B2">
-                <a:alpha val="18000"/>
-              </a:srgbClr>
-            </a:outerShdw>
-          </a:effectLst>
         </p:spPr>
       </p:sp>
       <p:sp>
@@ -11019,13 +10856,6 @@
             </a:solidFill>
             <a:prstDash val="solid"/>
           </a:ln>
-          <a:effectLst>
-            <a:outerShdw sx="100000" sy="100000" kx="0" ky="0" algn="bl" rotWithShape="0" blurRad="127000" dist="25400" dir="5400000">
-              <a:srgbClr val="9AA7B2">
-                <a:alpha val="18000"/>
-              </a:srgbClr>
-            </a:outerShdw>
-          </a:effectLst>
         </p:spPr>
       </p:sp>
       <p:sp>
@@ -11197,13 +11027,6 @@
             </a:solidFill>
             <a:prstDash val="solid"/>
           </a:ln>
-          <a:effectLst>
-            <a:outerShdw sx="100000" sy="100000" kx="0" ky="0" algn="bl" rotWithShape="0" blurRad="127000" dist="25400" dir="5400000">
-              <a:srgbClr val="9AA7B2">
-                <a:alpha val="18000"/>
-              </a:srgbClr>
-            </a:outerShdw>
-          </a:effectLst>
         </p:spPr>
       </p:sp>
       <p:sp>
@@ -12300,13 +12123,6 @@
             </a:solidFill>
             <a:prstDash val="solid"/>
           </a:ln>
-          <a:effectLst>
-            <a:outerShdw sx="100000" sy="100000" kx="0" ky="0" algn="bl" rotWithShape="0" blurRad="127000" dist="25400" dir="5400000">
-              <a:srgbClr val="9AA7B2">
-                <a:alpha val="18000"/>
-              </a:srgbClr>
-            </a:outerShdw>
-          </a:effectLst>
         </p:spPr>
       </p:sp>
       <p:sp>
@@ -12544,13 +12360,6 @@
             </a:solidFill>
             <a:prstDash val="solid"/>
           </a:ln>
-          <a:effectLst>
-            <a:outerShdw sx="100000" sy="100000" kx="0" ky="0" algn="bl" rotWithShape="0" blurRad="127000" dist="25400" dir="5400000">
-              <a:srgbClr val="9AA7B2">
-                <a:alpha val="18000"/>
-              </a:srgbClr>
-            </a:outerShdw>
-          </a:effectLst>
         </p:spPr>
       </p:sp>
       <p:sp>
@@ -12898,13 +12707,6 @@
             </a:solidFill>
             <a:prstDash val="solid"/>
           </a:ln>
-          <a:effectLst>
-            <a:outerShdw sx="100000" sy="100000" kx="0" ky="0" algn="bl" rotWithShape="0" blurRad="127000" dist="25400" dir="5400000">
-              <a:srgbClr val="9AA7B2">
-                <a:alpha val="18000"/>
-              </a:srgbClr>
-            </a:outerShdw>
-          </a:effectLst>
         </p:spPr>
       </p:sp>
       <p:sp>
@@ -13333,13 +13135,6 @@
             </a:solidFill>
             <a:prstDash val="solid"/>
           </a:ln>
-          <a:effectLst>
-            <a:outerShdw sx="100000" sy="100000" kx="0" ky="0" algn="bl" rotWithShape="0" blurRad="127000" dist="25400" dir="5400000">
-              <a:srgbClr val="9AA7B2">
-                <a:alpha val="18000"/>
-              </a:srgbClr>
-            </a:outerShdw>
-          </a:effectLst>
         </p:spPr>
       </p:sp>
       <p:sp>
@@ -13445,13 +13240,6 @@
             </a:solidFill>
             <a:prstDash val="solid"/>
           </a:ln>
-          <a:effectLst>
-            <a:outerShdw sx="100000" sy="100000" kx="0" ky="0" algn="bl" rotWithShape="0" blurRad="127000" dist="25400" dir="5400000">
-              <a:srgbClr val="9AA7B2">
-                <a:alpha val="18000"/>
-              </a:srgbClr>
-            </a:outerShdw>
-          </a:effectLst>
         </p:spPr>
       </p:sp>
       <p:sp>
@@ -13589,13 +13377,6 @@
             </a:solidFill>
             <a:prstDash val="solid"/>
           </a:ln>
-          <a:effectLst>
-            <a:outerShdw sx="100000" sy="100000" kx="0" ky="0" algn="bl" rotWithShape="0" blurRad="127000" dist="25400" dir="5400000">
-              <a:srgbClr val="9AA7B2">
-                <a:alpha val="18000"/>
-              </a:srgbClr>
-            </a:outerShdw>
-          </a:effectLst>
         </p:spPr>
       </p:sp>
       <p:sp>
@@ -14024,13 +13805,6 @@
             </a:solidFill>
             <a:prstDash val="solid"/>
           </a:ln>
-          <a:effectLst>
-            <a:outerShdw sx="100000" sy="100000" kx="0" ky="0" algn="bl" rotWithShape="0" blurRad="127000" dist="25400" dir="5400000">
-              <a:srgbClr val="9AA7B2">
-                <a:alpha val="18000"/>
-              </a:srgbClr>
-            </a:outerShdw>
-          </a:effectLst>
         </p:spPr>
       </p:sp>
       <p:sp>
@@ -14136,13 +13910,6 @@
             </a:solidFill>
             <a:prstDash val="solid"/>
           </a:ln>
-          <a:effectLst>
-            <a:outerShdw sx="100000" sy="100000" kx="0" ky="0" algn="bl" rotWithShape="0" blurRad="127000" dist="25400" dir="5400000">
-              <a:srgbClr val="9AA7B2">
-                <a:alpha val="18000"/>
-              </a:srgbClr>
-            </a:outerShdw>
-          </a:effectLst>
         </p:spPr>
       </p:sp>
       <p:sp>

</xml_diff>